<commit_message>
Fix iPhone mockup and ground submission hook in OECD evidence
</commit_message>
<xml_diff>
--- a/output/BACKTRACK_KEIC_2026.pptx
+++ b/output/BACKTRACK_KEIC_2026.pptx
@@ -620,7 +620,7 @@
           <a:p>
             <a:r>
               <a:rPr lang="en-US"/>
-              <a:t>Problem: understanding an explanation does not always make the next independent question straightforward. Dunlo connects a short-form starting point with practice and a useful return.</a:t>
+              <a:t>OECD’s PISA 2025 Philippines country note, published 8 September 2026, reports that 21% of participating Filipino 15-year-old students attained at least Level 2 in mathematics. The slide uses the complement: 100% − 21% = 79% below Level 2, the baseline proficiency threshold. The statistic describes school students represented by PISA, not all Filipinos. Source: https://www.oecd.org/en/publications/pisa-2025-results-volume-i-country-notes_2d4ff9ea-en/philippines_3699b9d5-en.html</a:t>
             </a:r>
             <a:endParaRPr lang="en-US" smtClean="0"/>
           </a:p>
@@ -6832,8 +6832,8 @@
         </p:nvSpPr>
         <p:spPr>
           <a:xfrm rot="0">
-            <a:off x="11239500" y="6353175"/>
-            <a:ext cx="428625" cy="168592"/>
+            <a:off x="762000" y="5743575"/>
+            <a:ext cx="10668000" cy="196596"/>
           </a:xfrm>
           <a:prstGeom prst="rect">
             <a:avLst/>
@@ -6847,14 +6847,103 @@
           <a:p>
             <a:pPr algn="l" marL="0" indent="0" lvl="0">
               <a:lnSpc>
-                <a:spcPts val="1372"/>
+                <a:spcPts val="1647"/>
               </a:lnSpc>
               <a:spcBef>
                 <a:spcPct val="0"/>
               </a:spcBef>
             </a:pPr>
             <a:r>
-              <a:rPr lang="en-US" sz="1125" strike="noStrike" u="none">
+              <a:rPr lang="en-US" sz="1350" strike="noStrike" u="none">
+                <a:solidFill>
+                  <a:srgbClr val="0A2A66"/>
+                </a:solidFill>
+                <a:latin typeface="DM Sans"/>
+                <a:ea typeface="DM Sans"/>
+                <a:cs typeface="DM Sans"/>
+                <a:sym typeface="DM Sans"/>
+                <a:hlinkClick r:id="rId7" tooltip="https://www.oecd.org/en/publications/pisa-2025-results-volume-i-country-notes_2d4ff9ea-en/philippines_3699b9d5-en.html"/>
+              </a:rPr>
+              <a:t>Source: OECD · PISA 2025, Philippines (2026) · Below Level 2 in mathematics</a:t>
+            </a:r>
+          </a:p>
+        </p:txBody>
+      </p:sp>
+      <p:sp>
+        <p:nvSpPr>
+          <p:cNvPr name="TextBox 9" id="9"/>
+          <p:cNvSpPr txBox="true"/>
+          <p:nvPr/>
+        </p:nvSpPr>
+        <p:spPr>
+          <a:xfrm rot="0">
+            <a:off x="762000" y="1600200"/>
+            <a:ext cx="10668000" cy="1592961"/>
+          </a:xfrm>
+          <a:prstGeom prst="rect">
+            <a:avLst/>
+          </a:prstGeom>
+        </p:spPr>
+        <p:txBody>
+          <a:bodyPr anchor="t" rtlCol="false" tIns="0" lIns="0" bIns="0" rIns="0">
+            <a:spAutoFit/>
+          </a:bodyPr>
+          <a:lstStyle/>
+          <a:p>
+            <a:pPr algn="l" marL="0" indent="0" lvl="0">
+              <a:lnSpc>
+                <a:spcPts val="12627"/>
+              </a:lnSpc>
+              <a:spcBef>
+                <a:spcPct val="0"/>
+              </a:spcBef>
+            </a:pPr>
+            <a:r>
+              <a:rPr lang="en-US" b="true" sz="10350" strike="noStrike" u="none">
+                <a:solidFill>
+                  <a:srgbClr val="0A2A66"/>
+                </a:solidFill>
+                <a:latin typeface="DM Sans Bold"/>
+                <a:ea typeface="DM Sans Bold"/>
+                <a:cs typeface="DM Sans Bold"/>
+                <a:sym typeface="DM Sans Bold"/>
+              </a:rPr>
+              <a:t>79%</a:t>
+            </a:r>
+          </a:p>
+        </p:txBody>
+      </p:sp>
+      <p:sp>
+        <p:nvSpPr>
+          <p:cNvPr name="TextBox 10" id="10"/>
+          <p:cNvSpPr txBox="true"/>
+          <p:nvPr/>
+        </p:nvSpPr>
+        <p:spPr>
+          <a:xfrm rot="0">
+            <a:off x="762000" y="3400425"/>
+            <a:ext cx="10668000" cy="973074"/>
+          </a:xfrm>
+          <a:prstGeom prst="rect">
+            <a:avLst/>
+          </a:prstGeom>
+        </p:spPr>
+        <p:txBody>
+          <a:bodyPr anchor="t" rtlCol="false" tIns="0" lIns="0" bIns="0" rIns="0">
+            <a:spAutoFit/>
+          </a:bodyPr>
+          <a:lstStyle/>
+          <a:p>
+            <a:pPr algn="l" marL="0" indent="0" lvl="0">
+              <a:lnSpc>
+                <a:spcPts val="3843"/>
+              </a:lnSpc>
+              <a:spcBef>
+                <a:spcPct val="0"/>
+              </a:spcBef>
+            </a:pPr>
+            <a:r>
+              <a:rPr lang="en-US" sz="3150" strike="noStrike" u="none">
                 <a:solidFill>
                   <a:srgbClr val="0A2A66"/>
                 </a:solidFill>
@@ -6863,95 +6952,29 @@
                 <a:cs typeface="DM Sans"/>
                 <a:sym typeface="DM Sans"/>
               </a:rPr>
-              <a:t>01</a:t>
-            </a:r>
-          </a:p>
-        </p:txBody>
-      </p:sp>
-      <p:sp>
-        <p:nvSpPr>
-          <p:cNvPr name="TextBox 9" id="9"/>
-          <p:cNvSpPr txBox="true"/>
-          <p:nvPr/>
-        </p:nvSpPr>
-        <p:spPr>
-          <a:xfrm rot="0">
-            <a:off x="762000" y="2352675"/>
-            <a:ext cx="10668000" cy="618363"/>
-          </a:xfrm>
-          <a:prstGeom prst="rect">
-            <a:avLst/>
-          </a:prstGeom>
-        </p:spPr>
-        <p:txBody>
-          <a:bodyPr anchor="t" rtlCol="false" tIns="0" lIns="0" bIns="0" rIns="0">
-            <a:spAutoFit/>
-          </a:bodyPr>
-          <a:lstStyle/>
+              <a:t>of Filipino 15-year-old students scored</a:t>
+            </a:r>
+          </a:p>
           <a:p>
             <a:pPr algn="l" marL="0" indent="0" lvl="0">
               <a:lnSpc>
-                <a:spcPts val="4941"/>
+                <a:spcPts val="3843"/>
               </a:lnSpc>
               <a:spcBef>
                 <a:spcPct val="0"/>
               </a:spcBef>
             </a:pPr>
             <a:r>
-              <a:rPr lang="en-US" b="true" sz="4050" strike="noStrike" u="none">
+              <a:rPr lang="en-US" sz="3150" strike="noStrike" u="none">
                 <a:solidFill>
                   <a:srgbClr val="0A2A66"/>
                 </a:solidFill>
-                <a:latin typeface="DM Sans Bold"/>
-                <a:ea typeface="DM Sans Bold"/>
-                <a:cs typeface="DM Sans Bold"/>
-                <a:sym typeface="DM Sans Bold"/>
+                <a:latin typeface="DM Sans"/>
+                <a:ea typeface="DM Sans"/>
+                <a:cs typeface="DM Sans"/>
+                <a:sym typeface="DM Sans"/>
               </a:rPr>
-              <a:t>The lesson makes sense.</a:t>
-            </a:r>
-          </a:p>
-        </p:txBody>
-      </p:sp>
-      <p:sp>
-        <p:nvSpPr>
-          <p:cNvPr name="TextBox 10" id="10"/>
-          <p:cNvSpPr txBox="true"/>
-          <p:nvPr/>
-        </p:nvSpPr>
-        <p:spPr>
-          <a:xfrm rot="0">
-            <a:off x="762000" y="3086100"/>
-            <a:ext cx="10668000" cy="618363"/>
-          </a:xfrm>
-          <a:prstGeom prst="rect">
-            <a:avLst/>
-          </a:prstGeom>
-        </p:spPr>
-        <p:txBody>
-          <a:bodyPr anchor="t" rtlCol="false" tIns="0" lIns="0" bIns="0" rIns="0">
-            <a:spAutoFit/>
-          </a:bodyPr>
-          <a:lstStyle/>
-          <a:p>
-            <a:pPr algn="l" marL="0" indent="0" lvl="0">
-              <a:lnSpc>
-                <a:spcPts val="4941"/>
-              </a:lnSpc>
-              <a:spcBef>
-                <a:spcPct val="0"/>
-              </a:spcBef>
-            </a:pPr>
-            <a:r>
-              <a:rPr lang="en-US" b="true" sz="4050" strike="noStrike" u="none">
-                <a:solidFill>
-                  <a:srgbClr val="0A2A66"/>
-                </a:solidFill>
-                <a:latin typeface="DM Sans Bold"/>
-                <a:ea typeface="DM Sans Bold"/>
-                <a:cs typeface="DM Sans Bold"/>
-                <a:sym typeface="DM Sans Bold"/>
-              </a:rPr>
-              <a:t>The next question doesn’t.</a:t>
+              <a:t>below basic proficiency in mathematics.</a:t>
             </a:r>
           </a:p>
         </p:txBody>
@@ -6995,15 +7018,67 @@
             </a:pathLst>
           </a:custGeom>
           <a:blipFill>
-            <a:blip r:embed="rId7">
+            <a:blip r:embed="rId8">
               <a:extLst>
                 <a:ext uri="{96DAC541-7B7A-43D3-8B79-37D633B846F1}">
-                  <asvg:svgBlip xmlns:asvg="http://schemas.microsoft.com/office/drawing/2016/SVG/main" r:embed="rId8"/>
+                  <asvg:svgBlip xmlns:asvg="http://schemas.microsoft.com/office/drawing/2016/SVG/main" r:embed="rId9"/>
                 </a:ext>
               </a:extLst>
             </a:blip>
             <a:stretch>
               <a:fillRect l="0" t="0" r="0" b="0"/>
+            </a:stretch>
+          </a:blipFill>
+        </p:spPr>
+      </p:sp>
+      <p:sp>
+        <p:nvSpPr>
+          <p:cNvPr name="Freeform 12" id="12"/>
+          <p:cNvSpPr/>
+          <p:nvPr/>
+        </p:nvSpPr>
+        <p:spPr>
+          <a:xfrm flipH="false" flipV="false" rot="0">
+            <a:off x="9429750" y="323850"/>
+            <a:ext cx="2152650" cy="133350"/>
+          </a:xfrm>
+          <a:custGeom>
+            <a:avLst/>
+            <a:gdLst/>
+            <a:ahLst/>
+            <a:cxnLst/>
+            <a:rect r="r" b="b" t="t" l="l"/>
+            <a:pathLst>
+              <a:path h="133350" w="2152650">
+                <a:moveTo>
+                  <a:pt x="0" y="0"/>
+                </a:moveTo>
+                <a:lnTo>
+                  <a:pt x="2152650" y="0"/>
+                </a:lnTo>
+                <a:lnTo>
+                  <a:pt x="2152650" y="133350"/>
+                </a:lnTo>
+                <a:lnTo>
+                  <a:pt x="0" y="133350"/>
+                </a:lnTo>
+                <a:lnTo>
+                  <a:pt x="0" y="0"/>
+                </a:lnTo>
+                <a:close/>
+              </a:path>
+            </a:pathLst>
+          </a:custGeom>
+          <a:blipFill>
+            <a:blip r:embed="rId10">
+              <a:extLst>
+                <a:ext uri="{96DAC541-7B7A-43D3-8B79-37D633B846F1}">
+                  <asvg:svgBlip xmlns:asvg="http://schemas.microsoft.com/office/drawing/2016/SVG/main" r:embed="rId11"/>
+                </a:ext>
+              </a:extLst>
+            </a:blip>
+            <a:stretch>
+              <a:fillRect l="0" t="-1363" r="0" b="-1363"/>
             </a:stretch>
           </a:blipFill>
         </p:spPr>
@@ -8116,6 +8191,58 @@
           </a:blipFill>
         </p:spPr>
       </p:sp>
+      <p:sp>
+        <p:nvSpPr>
+          <p:cNvPr name="Freeform 31" id="31"/>
+          <p:cNvSpPr/>
+          <p:nvPr/>
+        </p:nvSpPr>
+        <p:spPr>
+          <a:xfrm flipH="false" flipV="false" rot="0">
+            <a:off x="9429750" y="323850"/>
+            <a:ext cx="2152650" cy="133350"/>
+          </a:xfrm>
+          <a:custGeom>
+            <a:avLst/>
+            <a:gdLst/>
+            <a:ahLst/>
+            <a:cxnLst/>
+            <a:rect r="r" b="b" t="t" l="l"/>
+            <a:pathLst>
+              <a:path h="133350" w="2152650">
+                <a:moveTo>
+                  <a:pt x="0" y="0"/>
+                </a:moveTo>
+                <a:lnTo>
+                  <a:pt x="2152650" y="0"/>
+                </a:lnTo>
+                <a:lnTo>
+                  <a:pt x="2152650" y="133350"/>
+                </a:lnTo>
+                <a:lnTo>
+                  <a:pt x="0" y="133350"/>
+                </a:lnTo>
+                <a:lnTo>
+                  <a:pt x="0" y="0"/>
+                </a:lnTo>
+                <a:close/>
+              </a:path>
+            </a:pathLst>
+          </a:custGeom>
+          <a:blipFill>
+            <a:blip r:embed="rId10">
+              <a:extLst>
+                <a:ext uri="{96DAC541-7B7A-43D3-8B79-37D633B846F1}">
+                  <asvg:svgBlip xmlns:asvg="http://schemas.microsoft.com/office/drawing/2016/SVG/main" r:embed="rId11"/>
+                </a:ext>
+              </a:extLst>
+            </a:blip>
+            <a:stretch>
+              <a:fillRect l="0" t="-1363" r="0" b="-1363"/>
+            </a:stretch>
+          </a:blipFill>
+        </p:spPr>
+      </p:sp>
     </p:spTree>
   </p:cSld>
   <p:clrMapOvr>
@@ -9465,6 +9592,58 @@
           </a:blipFill>
         </p:spPr>
       </p:sp>
+      <p:sp>
+        <p:nvSpPr>
+          <p:cNvPr name="Freeform 38" id="38"/>
+          <p:cNvSpPr/>
+          <p:nvPr/>
+        </p:nvSpPr>
+        <p:spPr>
+          <a:xfrm flipH="false" flipV="false" rot="0">
+            <a:off x="9429750" y="323850"/>
+            <a:ext cx="2152650" cy="133350"/>
+          </a:xfrm>
+          <a:custGeom>
+            <a:avLst/>
+            <a:gdLst/>
+            <a:ahLst/>
+            <a:cxnLst/>
+            <a:rect r="r" b="b" t="t" l="l"/>
+            <a:pathLst>
+              <a:path h="133350" w="2152650">
+                <a:moveTo>
+                  <a:pt x="0" y="0"/>
+                </a:moveTo>
+                <a:lnTo>
+                  <a:pt x="2152650" y="0"/>
+                </a:lnTo>
+                <a:lnTo>
+                  <a:pt x="2152650" y="133350"/>
+                </a:lnTo>
+                <a:lnTo>
+                  <a:pt x="0" y="133350"/>
+                </a:lnTo>
+                <a:lnTo>
+                  <a:pt x="0" y="0"/>
+                </a:lnTo>
+                <a:close/>
+              </a:path>
+            </a:pathLst>
+          </a:custGeom>
+          <a:blipFill>
+            <a:blip r:embed="rId9">
+              <a:extLst>
+                <a:ext uri="{96DAC541-7B7A-43D3-8B79-37D633B846F1}">
+                  <asvg:svgBlip xmlns:asvg="http://schemas.microsoft.com/office/drawing/2016/SVG/main" r:embed="rId10"/>
+                </a:ext>
+              </a:extLst>
+            </a:blip>
+            <a:stretch>
+              <a:fillRect l="0" t="-1363" r="0" b="-1363"/>
+            </a:stretch>
+          </a:blipFill>
+        </p:spPr>
+      </p:sp>
     </p:spTree>
   </p:cSld>
   <p:clrMapOvr>
@@ -10362,6 +10541,58 @@
             </a:blip>
             <a:stretch>
               <a:fillRect l="0" t="0" r="0" b="0"/>
+            </a:stretch>
+          </a:blipFill>
+        </p:spPr>
+      </p:sp>
+      <p:sp>
+        <p:nvSpPr>
+          <p:cNvPr name="Freeform 22" id="22"/>
+          <p:cNvSpPr/>
+          <p:nvPr/>
+        </p:nvSpPr>
+        <p:spPr>
+          <a:xfrm flipH="false" flipV="false" rot="0">
+            <a:off x="9429750" y="323850"/>
+            <a:ext cx="2152650" cy="133350"/>
+          </a:xfrm>
+          <a:custGeom>
+            <a:avLst/>
+            <a:gdLst/>
+            <a:ahLst/>
+            <a:cxnLst/>
+            <a:rect r="r" b="b" t="t" l="l"/>
+            <a:pathLst>
+              <a:path h="133350" w="2152650">
+                <a:moveTo>
+                  <a:pt x="0" y="0"/>
+                </a:moveTo>
+                <a:lnTo>
+                  <a:pt x="2152650" y="0"/>
+                </a:lnTo>
+                <a:lnTo>
+                  <a:pt x="2152650" y="133350"/>
+                </a:lnTo>
+                <a:lnTo>
+                  <a:pt x="0" y="133350"/>
+                </a:lnTo>
+                <a:lnTo>
+                  <a:pt x="0" y="0"/>
+                </a:lnTo>
+                <a:close/>
+              </a:path>
+            </a:pathLst>
+          </a:custGeom>
+          <a:blipFill>
+            <a:blip r:embed="rId9">
+              <a:extLst>
+                <a:ext uri="{96DAC541-7B7A-43D3-8B79-37D633B846F1}">
+                  <asvg:svgBlip xmlns:asvg="http://schemas.microsoft.com/office/drawing/2016/SVG/main" r:embed="rId10"/>
+                </a:ext>
+              </a:extLst>
+            </a:blip>
+            <a:stretch>
+              <a:fillRect l="0" t="-1363" r="0" b="-1363"/>
             </a:stretch>
           </a:blipFill>
         </p:spPr>
@@ -14031,6 +14262,58 @@
           </a:blipFill>
         </p:spPr>
       </p:sp>
+      <p:sp>
+        <p:nvSpPr>
+          <p:cNvPr name="Freeform 97" id="97"/>
+          <p:cNvSpPr/>
+          <p:nvPr/>
+        </p:nvSpPr>
+        <p:spPr>
+          <a:xfrm flipH="false" flipV="false" rot="0">
+            <a:off x="9429750" y="323850"/>
+            <a:ext cx="2152650" cy="133350"/>
+          </a:xfrm>
+          <a:custGeom>
+            <a:avLst/>
+            <a:gdLst/>
+            <a:ahLst/>
+            <a:cxnLst/>
+            <a:rect r="r" b="b" t="t" l="l"/>
+            <a:pathLst>
+              <a:path h="133350" w="2152650">
+                <a:moveTo>
+                  <a:pt x="0" y="0"/>
+                </a:moveTo>
+                <a:lnTo>
+                  <a:pt x="2152650" y="0"/>
+                </a:lnTo>
+                <a:lnTo>
+                  <a:pt x="2152650" y="133350"/>
+                </a:lnTo>
+                <a:lnTo>
+                  <a:pt x="0" y="133350"/>
+                </a:lnTo>
+                <a:lnTo>
+                  <a:pt x="0" y="0"/>
+                </a:lnTo>
+                <a:close/>
+              </a:path>
+            </a:pathLst>
+          </a:custGeom>
+          <a:blipFill>
+            <a:blip r:embed="rId10">
+              <a:extLst>
+                <a:ext uri="{96DAC541-7B7A-43D3-8B79-37D633B846F1}">
+                  <asvg:svgBlip xmlns:asvg="http://schemas.microsoft.com/office/drawing/2016/SVG/main" r:embed="rId11"/>
+                </a:ext>
+              </a:extLst>
+            </a:blip>
+            <a:stretch>
+              <a:fillRect l="0" t="-1363" r="0" b="-1363"/>
+            </a:stretch>
+          </a:blipFill>
+        </p:spPr>
+      </p:sp>
     </p:spTree>
   </p:cSld>
   <p:clrMapOvr>
@@ -14566,6 +14849,58 @@
           </a:blipFill>
         </p:spPr>
       </p:sp>
+      <p:sp>
+        <p:nvSpPr>
+          <p:cNvPr name="Freeform 14" id="14"/>
+          <p:cNvSpPr/>
+          <p:nvPr/>
+        </p:nvSpPr>
+        <p:spPr>
+          <a:xfrm flipH="false" flipV="false" rot="0">
+            <a:off x="9429750" y="323850"/>
+            <a:ext cx="2152650" cy="133350"/>
+          </a:xfrm>
+          <a:custGeom>
+            <a:avLst/>
+            <a:gdLst/>
+            <a:ahLst/>
+            <a:cxnLst/>
+            <a:rect r="r" b="b" t="t" l="l"/>
+            <a:pathLst>
+              <a:path h="133350" w="2152650">
+                <a:moveTo>
+                  <a:pt x="0" y="0"/>
+                </a:moveTo>
+                <a:lnTo>
+                  <a:pt x="2152650" y="0"/>
+                </a:lnTo>
+                <a:lnTo>
+                  <a:pt x="2152650" y="133350"/>
+                </a:lnTo>
+                <a:lnTo>
+                  <a:pt x="0" y="133350"/>
+                </a:lnTo>
+                <a:lnTo>
+                  <a:pt x="0" y="0"/>
+                </a:lnTo>
+                <a:close/>
+              </a:path>
+            </a:pathLst>
+          </a:custGeom>
+          <a:blipFill>
+            <a:blip r:embed="rId10">
+              <a:extLst>
+                <a:ext uri="{96DAC541-7B7A-43D3-8B79-37D633B846F1}">
+                  <asvg:svgBlip xmlns:asvg="http://schemas.microsoft.com/office/drawing/2016/SVG/main" r:embed="rId11"/>
+                </a:ext>
+              </a:extLst>
+            </a:blip>
+            <a:stretch>
+              <a:fillRect l="0" t="-1363" r="0" b="-1363"/>
+            </a:stretch>
+          </a:blipFill>
+        </p:spPr>
+      </p:sp>
     </p:spTree>
   </p:cSld>
   <p:clrMapOvr>
@@ -15654,6 +15989,58 @@
           </a:blipFill>
         </p:spPr>
       </p:sp>
+      <p:sp>
+        <p:nvSpPr>
+          <p:cNvPr name="Freeform 19" id="19"/>
+          <p:cNvSpPr/>
+          <p:nvPr/>
+        </p:nvSpPr>
+        <p:spPr>
+          <a:xfrm flipH="false" flipV="false" rot="0">
+            <a:off x="9429750" y="323850"/>
+            <a:ext cx="2152650" cy="133350"/>
+          </a:xfrm>
+          <a:custGeom>
+            <a:avLst/>
+            <a:gdLst/>
+            <a:ahLst/>
+            <a:cxnLst/>
+            <a:rect r="r" b="b" t="t" l="l"/>
+            <a:pathLst>
+              <a:path h="133350" w="2152650">
+                <a:moveTo>
+                  <a:pt x="0" y="0"/>
+                </a:moveTo>
+                <a:lnTo>
+                  <a:pt x="2152650" y="0"/>
+                </a:lnTo>
+                <a:lnTo>
+                  <a:pt x="2152650" y="133350"/>
+                </a:lnTo>
+                <a:lnTo>
+                  <a:pt x="0" y="133350"/>
+                </a:lnTo>
+                <a:lnTo>
+                  <a:pt x="0" y="0"/>
+                </a:lnTo>
+                <a:close/>
+              </a:path>
+            </a:pathLst>
+          </a:custGeom>
+          <a:blipFill>
+            <a:blip r:embed="rId33">
+              <a:extLst>
+                <a:ext uri="{96DAC541-7B7A-43D3-8B79-37D633B846F1}">
+                  <asvg:svgBlip xmlns:asvg="http://schemas.microsoft.com/office/drawing/2016/SVG/main" r:embed="rId34"/>
+                </a:ext>
+              </a:extLst>
+            </a:blip>
+            <a:stretch>
+              <a:fillRect l="0" t="-1363" r="0" b="-1363"/>
+            </a:stretch>
+          </a:blipFill>
+        </p:spPr>
+      </p:sp>
     </p:spTree>
   </p:cSld>
   <p:clrMapOvr>
@@ -16673,6 +17060,58 @@
             </a:blip>
             <a:stretch>
               <a:fillRect l="0" t="0" r="0" b="0"/>
+            </a:stretch>
+          </a:blipFill>
+        </p:spPr>
+      </p:sp>
+      <p:sp>
+        <p:nvSpPr>
+          <p:cNvPr name="Freeform 27" id="27"/>
+          <p:cNvSpPr/>
+          <p:nvPr/>
+        </p:nvSpPr>
+        <p:spPr>
+          <a:xfrm flipH="false" flipV="false" rot="0">
+            <a:off x="9429750" y="323850"/>
+            <a:ext cx="2152650" cy="133350"/>
+          </a:xfrm>
+          <a:custGeom>
+            <a:avLst/>
+            <a:gdLst/>
+            <a:ahLst/>
+            <a:cxnLst/>
+            <a:rect r="r" b="b" t="t" l="l"/>
+            <a:pathLst>
+              <a:path h="133350" w="2152650">
+                <a:moveTo>
+                  <a:pt x="0" y="0"/>
+                </a:moveTo>
+                <a:lnTo>
+                  <a:pt x="2152650" y="0"/>
+                </a:lnTo>
+                <a:lnTo>
+                  <a:pt x="2152650" y="133350"/>
+                </a:lnTo>
+                <a:lnTo>
+                  <a:pt x="0" y="133350"/>
+                </a:lnTo>
+                <a:lnTo>
+                  <a:pt x="0" y="0"/>
+                </a:lnTo>
+                <a:close/>
+              </a:path>
+            </a:pathLst>
+          </a:custGeom>
+          <a:blipFill>
+            <a:blip r:embed="rId9">
+              <a:extLst>
+                <a:ext uri="{96DAC541-7B7A-43D3-8B79-37D633B846F1}">
+                  <asvg:svgBlip xmlns:asvg="http://schemas.microsoft.com/office/drawing/2016/SVG/main" r:embed="rId10"/>
+                </a:ext>
+              </a:extLst>
+            </a:blip>
+            <a:stretch>
+              <a:fillRect l="0" t="-1363" r="0" b="-1363"/>
             </a:stretch>
           </a:blipFill>
         </p:spPr>
@@ -18320,6 +18759,58 @@
           </a:blipFill>
         </p:spPr>
       </p:sp>
+      <p:sp>
+        <p:nvSpPr>
+          <p:cNvPr name="Freeform 44" id="44"/>
+          <p:cNvSpPr/>
+          <p:nvPr/>
+        </p:nvSpPr>
+        <p:spPr>
+          <a:xfrm flipH="false" flipV="false" rot="0">
+            <a:off x="9429750" y="323850"/>
+            <a:ext cx="2152650" cy="133350"/>
+          </a:xfrm>
+          <a:custGeom>
+            <a:avLst/>
+            <a:gdLst/>
+            <a:ahLst/>
+            <a:cxnLst/>
+            <a:rect r="r" b="b" t="t" l="l"/>
+            <a:pathLst>
+              <a:path h="133350" w="2152650">
+                <a:moveTo>
+                  <a:pt x="0" y="0"/>
+                </a:moveTo>
+                <a:lnTo>
+                  <a:pt x="2152650" y="0"/>
+                </a:lnTo>
+                <a:lnTo>
+                  <a:pt x="2152650" y="133350"/>
+                </a:lnTo>
+                <a:lnTo>
+                  <a:pt x="0" y="133350"/>
+                </a:lnTo>
+                <a:lnTo>
+                  <a:pt x="0" y="0"/>
+                </a:lnTo>
+                <a:close/>
+              </a:path>
+            </a:pathLst>
+          </a:custGeom>
+          <a:blipFill>
+            <a:blip r:embed="rId11">
+              <a:extLst>
+                <a:ext uri="{96DAC541-7B7A-43D3-8B79-37D633B846F1}">
+                  <asvg:svgBlip xmlns:asvg="http://schemas.microsoft.com/office/drawing/2016/SVG/main" r:embed="rId12"/>
+                </a:ext>
+              </a:extLst>
+            </a:blip>
+            <a:stretch>
+              <a:fillRect l="0" t="-1363" r="0" b="-1363"/>
+            </a:stretch>
+          </a:blipFill>
+        </p:spPr>
+      </p:sp>
     </p:spTree>
   </p:cSld>
   <p:clrMapOvr>
@@ -18380,7 +18871,13 @@
         </p:grpSpPr>
         <p:sp>
           <p:nvSpPr>
-            <p:cNvPr name="Freeform 4" id="4"/>
+            <p:cNvPr name="Freeform 4" id="4">
+              <a:extLst>
+                <a:ext uri="{C183D7F6-B498-43B3-948B-1728B52AA6E4}">
+                  <adec:decorative xmlns:adec="http://schemas.microsoft.com/office/drawing/2017/decorative" val="1"/>
+                </a:ext>
+              </a:extLst>
+            </p:cNvPr>
             <p:cNvSpPr/>
             <p:nvPr/>
           </p:nvSpPr>
@@ -18622,6 +19119,272 @@
         </p:nvSpPr>
         <p:spPr>
           <a:xfrm rot="0">
+            <a:off x="609600" y="1790700"/>
+            <a:ext cx="7000875" cy="604456"/>
+          </a:xfrm>
+          <a:prstGeom prst="rect">
+            <a:avLst/>
+          </a:prstGeom>
+        </p:spPr>
+        <p:txBody>
+          <a:bodyPr anchor="t" rtlCol="false" tIns="0" lIns="0" bIns="0" rIns="0">
+            <a:spAutoFit/>
+          </a:bodyPr>
+          <a:lstStyle/>
+          <a:p>
+            <a:pPr algn="l" marL="0" indent="0" lvl="0">
+              <a:lnSpc>
+                <a:spcPts val="2470"/>
+              </a:lnSpc>
+              <a:spcBef>
+                <a:spcPct val="0"/>
+              </a:spcBef>
+            </a:pPr>
+            <a:r>
+              <a:rPr lang="en-US" sz="2025" strike="noStrike" u="none">
+                <a:solidFill>
+                  <a:srgbClr val="0A2A66"/>
+                </a:solidFill>
+                <a:latin typeface="DM Sans"/>
+                <a:ea typeface="DM Sans"/>
+                <a:cs typeface="DM Sans"/>
+                <a:sym typeface="DM Sans"/>
+              </a:rPr>
+              <a:t>For learners used to mobile feeds,</a:t>
+            </a:r>
+          </a:p>
+          <a:p>
+            <a:pPr algn="l" marL="0" indent="0" lvl="0">
+              <a:lnSpc>
+                <a:spcPts val="2470"/>
+              </a:lnSpc>
+              <a:spcBef>
+                <a:spcPct val="0"/>
+              </a:spcBef>
+            </a:pPr>
+            <a:r>
+              <a:rPr lang="en-US" sz="2025" strike="noStrike" u="none">
+                <a:solidFill>
+                  <a:srgbClr val="0A2A66"/>
+                </a:solidFill>
+                <a:latin typeface="DM Sans"/>
+                <a:ea typeface="DM Sans"/>
+                <a:cs typeface="DM Sans"/>
+                <a:sym typeface="DM Sans"/>
+              </a:rPr>
+              <a:t>Dunlo makes one idea easy to start.</a:t>
+            </a:r>
+          </a:p>
+        </p:txBody>
+      </p:sp>
+      <p:sp>
+        <p:nvSpPr>
+          <p:cNvPr name="TextBox 11" id="11"/>
+          <p:cNvSpPr txBox="true"/>
+          <p:nvPr/>
+        </p:nvSpPr>
+        <p:spPr>
+          <a:xfrm rot="0">
+            <a:off x="609600" y="2838450"/>
+            <a:ext cx="7048500" cy="393573"/>
+          </a:xfrm>
+          <a:prstGeom prst="rect">
+            <a:avLst/>
+          </a:prstGeom>
+        </p:spPr>
+        <p:txBody>
+          <a:bodyPr anchor="t" rtlCol="false" tIns="0" lIns="0" bIns="0" rIns="0">
+            <a:spAutoFit/>
+          </a:bodyPr>
+          <a:lstStyle/>
+          <a:p>
+            <a:pPr algn="l" marL="0" indent="0" lvl="0">
+              <a:lnSpc>
+                <a:spcPts val="3111"/>
+              </a:lnSpc>
+              <a:spcBef>
+                <a:spcPct val="0"/>
+              </a:spcBef>
+            </a:pPr>
+            <a:r>
+              <a:rPr lang="en-US" b="true" sz="2550" strike="noStrike" u="none">
+                <a:solidFill>
+                  <a:srgbClr val="0A2A66"/>
+                </a:solidFill>
+                <a:latin typeface="DM Sans Bold"/>
+                <a:ea typeface="DM Sans Bold"/>
+                <a:cs typeface="DM Sans Bold"/>
+                <a:sym typeface="DM Sans Bold"/>
+              </a:rPr>
+              <a:t>Scroll. Try. Keep going.</a:t>
+            </a:r>
+          </a:p>
+        </p:txBody>
+      </p:sp>
+      <p:sp>
+        <p:nvSpPr>
+          <p:cNvPr name="TextBox 12" id="12"/>
+          <p:cNvSpPr txBox="true"/>
+          <p:nvPr/>
+        </p:nvSpPr>
+        <p:spPr>
+          <a:xfrm rot="0">
+            <a:off x="609600" y="3448050"/>
+            <a:ext cx="7048500" cy="604456"/>
+          </a:xfrm>
+          <a:prstGeom prst="rect">
+            <a:avLst/>
+          </a:prstGeom>
+        </p:spPr>
+        <p:txBody>
+          <a:bodyPr anchor="t" rtlCol="false" tIns="0" lIns="0" bIns="0" rIns="0">
+            <a:spAutoFit/>
+          </a:bodyPr>
+          <a:lstStyle/>
+          <a:p>
+            <a:pPr algn="l" marL="0" indent="0" lvl="0">
+              <a:lnSpc>
+                <a:spcPts val="2470"/>
+              </a:lnSpc>
+              <a:spcBef>
+                <a:spcPct val="0"/>
+              </a:spcBef>
+            </a:pPr>
+            <a:r>
+              <a:rPr lang="en-US" sz="2025" strike="noStrike" u="none">
+                <a:solidFill>
+                  <a:srgbClr val="0A2A66"/>
+                </a:solidFill>
+                <a:latin typeface="DM Sans"/>
+                <a:ea typeface="DM Sans"/>
+                <a:cs typeface="DM Sans"/>
+                <a:sym typeface="DM Sans"/>
+              </a:rPr>
+              <a:t>Move a slider or watch a focused Khan clip.</a:t>
+            </a:r>
+          </a:p>
+          <a:p>
+            <a:pPr algn="l" marL="0" indent="0" lvl="0">
+              <a:lnSpc>
+                <a:spcPts val="2470"/>
+              </a:lnSpc>
+              <a:spcBef>
+                <a:spcPct val="0"/>
+              </a:spcBef>
+            </a:pPr>
+            <a:r>
+              <a:rPr lang="en-US" sz="2025" strike="noStrike" u="none">
+                <a:solidFill>
+                  <a:srgbClr val="0A2A66"/>
+                </a:solidFill>
+                <a:latin typeface="DM Sans"/>
+                <a:ea typeface="DM Sans"/>
+                <a:cs typeface="DM Sans"/>
+                <a:sym typeface="DM Sans"/>
+              </a:rPr>
+              <a:t>Make a prediction and get an explanation.</a:t>
+            </a:r>
+          </a:p>
+        </p:txBody>
+      </p:sp>
+      <p:sp>
+        <p:nvSpPr>
+          <p:cNvPr name="TextBox 13" id="13"/>
+          <p:cNvSpPr txBox="true"/>
+          <p:nvPr/>
+        </p:nvSpPr>
+        <p:spPr>
+          <a:xfrm rot="0">
+            <a:off x="609600" y="4686300"/>
+            <a:ext cx="7334250" cy="604456"/>
+          </a:xfrm>
+          <a:prstGeom prst="rect">
+            <a:avLst/>
+          </a:prstGeom>
+        </p:spPr>
+        <p:txBody>
+          <a:bodyPr anchor="t" rtlCol="false" tIns="0" lIns="0" bIns="0" rIns="0">
+            <a:spAutoFit/>
+          </a:bodyPr>
+          <a:lstStyle/>
+          <a:p>
+            <a:pPr algn="l" marL="0" indent="0" lvl="0">
+              <a:lnSpc>
+                <a:spcPts val="2470"/>
+              </a:lnSpc>
+              <a:spcBef>
+                <a:spcPct val="0"/>
+              </a:spcBef>
+            </a:pPr>
+            <a:r>
+              <a:rPr lang="en-US" sz="2025" strike="noStrike" u="none">
+                <a:solidFill>
+                  <a:srgbClr val="0A2A66"/>
+                </a:solidFill>
+                <a:latin typeface="DM Sans"/>
+                <a:ea typeface="DM Sans"/>
+                <a:cs typeface="DM Sans"/>
+                <a:sym typeface="DM Sans"/>
+              </a:rPr>
+              <a:t>Follow the idea into a matching Khan exercise.</a:t>
+            </a:r>
+          </a:p>
+          <a:p>
+            <a:pPr algn="l" marL="0" indent="0" lvl="0">
+              <a:lnSpc>
+                <a:spcPts val="2470"/>
+              </a:lnSpc>
+              <a:spcBef>
+                <a:spcPct val="0"/>
+              </a:spcBef>
+            </a:pPr>
+            <a:r>
+              <a:rPr lang="en-US" sz="2025" strike="noStrike" u="none">
+                <a:solidFill>
+                  <a:srgbClr val="0A2A66"/>
+                </a:solidFill>
+                <a:latin typeface="DM Sans"/>
+                <a:ea typeface="DM Sans"/>
+                <a:cs typeface="DM Sans"/>
+                <a:sym typeface="DM Sans"/>
+              </a:rPr>
+              <a:t>Save it for a fresh question later.</a:t>
+            </a:r>
+          </a:p>
+        </p:txBody>
+      </p:sp>
+      <p:pic>
+        <p:nvPicPr>
+          <p:cNvPr name="Picture 14" id="14"/>
+          <p:cNvPicPr>
+            <a:picLocks noChangeAspect="true"/>
+          </p:cNvPicPr>
+          <p:nvPr/>
+        </p:nvPicPr>
+        <p:blipFill>
+          <a:blip r:embed="rId9"/>
+          <a:stretch>
+            <a:fillRect/>
+          </a:stretch>
+        </p:blipFill>
+        <p:spPr>
+          <a:xfrm rot="0">
+            <a:off x="7986495" y="1033245"/>
+            <a:ext cx="3362760" cy="5889061"/>
+          </a:xfrm>
+          <a:prstGeom prst="rect">
+            <a:avLst/>
+          </a:prstGeom>
+        </p:spPr>
+      </p:pic>
+      <p:sp>
+        <p:nvSpPr>
+          <p:cNvPr name="TextBox 15" id="15"/>
+          <p:cNvSpPr txBox="true"/>
+          <p:nvPr/>
+        </p:nvSpPr>
+        <p:spPr>
+          <a:xfrm rot="0">
             <a:off x="609600" y="866775"/>
             <a:ext cx="10972800" cy="487299"/>
           </a:xfrm>
@@ -18660,249 +19423,7 @@
       </p:sp>
       <p:sp>
         <p:nvSpPr>
-          <p:cNvPr name="TextBox 11" id="11"/>
-          <p:cNvSpPr txBox="true"/>
-          <p:nvPr/>
-        </p:nvSpPr>
-        <p:spPr>
-          <a:xfrm rot="0">
-            <a:off x="609600" y="1790700"/>
-            <a:ext cx="7000875" cy="604456"/>
-          </a:xfrm>
-          <a:prstGeom prst="rect">
-            <a:avLst/>
-          </a:prstGeom>
-        </p:spPr>
-        <p:txBody>
-          <a:bodyPr anchor="t" rtlCol="false" tIns="0" lIns="0" bIns="0" rIns="0">
-            <a:spAutoFit/>
-          </a:bodyPr>
-          <a:lstStyle/>
-          <a:p>
-            <a:pPr algn="l" marL="0" indent="0" lvl="0">
-              <a:lnSpc>
-                <a:spcPts val="2470"/>
-              </a:lnSpc>
-              <a:spcBef>
-                <a:spcPct val="0"/>
-              </a:spcBef>
-            </a:pPr>
-            <a:r>
-              <a:rPr lang="en-US" sz="2025" strike="noStrike" u="none">
-                <a:solidFill>
-                  <a:srgbClr val="0A2A66"/>
-                </a:solidFill>
-                <a:latin typeface="DM Sans"/>
-                <a:ea typeface="DM Sans"/>
-                <a:cs typeface="DM Sans"/>
-                <a:sym typeface="DM Sans"/>
-              </a:rPr>
-              <a:t>For learners used to mobile feeds,</a:t>
-            </a:r>
-          </a:p>
-          <a:p>
-            <a:pPr algn="l" marL="0" indent="0" lvl="0">
-              <a:lnSpc>
-                <a:spcPts val="2470"/>
-              </a:lnSpc>
-              <a:spcBef>
-                <a:spcPct val="0"/>
-              </a:spcBef>
-            </a:pPr>
-            <a:r>
-              <a:rPr lang="en-US" sz="2025" strike="noStrike" u="none">
-                <a:solidFill>
-                  <a:srgbClr val="0A2A66"/>
-                </a:solidFill>
-                <a:latin typeface="DM Sans"/>
-                <a:ea typeface="DM Sans"/>
-                <a:cs typeface="DM Sans"/>
-                <a:sym typeface="DM Sans"/>
-              </a:rPr>
-              <a:t>Dunlo makes one idea easy to start.</a:t>
-            </a:r>
-          </a:p>
-        </p:txBody>
-      </p:sp>
-      <p:sp>
-        <p:nvSpPr>
-          <p:cNvPr name="TextBox 12" id="12"/>
-          <p:cNvSpPr txBox="true"/>
-          <p:nvPr/>
-        </p:nvSpPr>
-        <p:spPr>
-          <a:xfrm rot="0">
-            <a:off x="609600" y="2838450"/>
-            <a:ext cx="7048500" cy="393573"/>
-          </a:xfrm>
-          <a:prstGeom prst="rect">
-            <a:avLst/>
-          </a:prstGeom>
-        </p:spPr>
-        <p:txBody>
-          <a:bodyPr anchor="t" rtlCol="false" tIns="0" lIns="0" bIns="0" rIns="0">
-            <a:spAutoFit/>
-          </a:bodyPr>
-          <a:lstStyle/>
-          <a:p>
-            <a:pPr algn="l" marL="0" indent="0" lvl="0">
-              <a:lnSpc>
-                <a:spcPts val="3111"/>
-              </a:lnSpc>
-              <a:spcBef>
-                <a:spcPct val="0"/>
-              </a:spcBef>
-            </a:pPr>
-            <a:r>
-              <a:rPr lang="en-US" b="true" sz="2550" strike="noStrike" u="none">
-                <a:solidFill>
-                  <a:srgbClr val="0A2A66"/>
-                </a:solidFill>
-                <a:latin typeface="DM Sans Bold"/>
-                <a:ea typeface="DM Sans Bold"/>
-                <a:cs typeface="DM Sans Bold"/>
-                <a:sym typeface="DM Sans Bold"/>
-              </a:rPr>
-              <a:t>Scroll. Try. Keep going.</a:t>
-            </a:r>
-          </a:p>
-        </p:txBody>
-      </p:sp>
-      <p:sp>
-        <p:nvSpPr>
-          <p:cNvPr name="TextBox 13" id="13"/>
-          <p:cNvSpPr txBox="true"/>
-          <p:nvPr/>
-        </p:nvSpPr>
-        <p:spPr>
-          <a:xfrm rot="0">
-            <a:off x="609600" y="3448050"/>
-            <a:ext cx="7048500" cy="604456"/>
-          </a:xfrm>
-          <a:prstGeom prst="rect">
-            <a:avLst/>
-          </a:prstGeom>
-        </p:spPr>
-        <p:txBody>
-          <a:bodyPr anchor="t" rtlCol="false" tIns="0" lIns="0" bIns="0" rIns="0">
-            <a:spAutoFit/>
-          </a:bodyPr>
-          <a:lstStyle/>
-          <a:p>
-            <a:pPr algn="l" marL="0" indent="0" lvl="0">
-              <a:lnSpc>
-                <a:spcPts val="2470"/>
-              </a:lnSpc>
-              <a:spcBef>
-                <a:spcPct val="0"/>
-              </a:spcBef>
-            </a:pPr>
-            <a:r>
-              <a:rPr lang="en-US" sz="2025" strike="noStrike" u="none">
-                <a:solidFill>
-                  <a:srgbClr val="0A2A66"/>
-                </a:solidFill>
-                <a:latin typeface="DM Sans"/>
-                <a:ea typeface="DM Sans"/>
-                <a:cs typeface="DM Sans"/>
-                <a:sym typeface="DM Sans"/>
-              </a:rPr>
-              <a:t>Move a slider or watch a focused Khan clip.</a:t>
-            </a:r>
-          </a:p>
-          <a:p>
-            <a:pPr algn="l" marL="0" indent="0" lvl="0">
-              <a:lnSpc>
-                <a:spcPts val="2470"/>
-              </a:lnSpc>
-              <a:spcBef>
-                <a:spcPct val="0"/>
-              </a:spcBef>
-            </a:pPr>
-            <a:r>
-              <a:rPr lang="en-US" sz="2025" strike="noStrike" u="none">
-                <a:solidFill>
-                  <a:srgbClr val="0A2A66"/>
-                </a:solidFill>
-                <a:latin typeface="DM Sans"/>
-                <a:ea typeface="DM Sans"/>
-                <a:cs typeface="DM Sans"/>
-                <a:sym typeface="DM Sans"/>
-              </a:rPr>
-              <a:t>Make a prediction and get an explanation.</a:t>
-            </a:r>
-          </a:p>
-        </p:txBody>
-      </p:sp>
-      <p:sp>
-        <p:nvSpPr>
-          <p:cNvPr name="TextBox 14" id="14"/>
-          <p:cNvSpPr txBox="true"/>
-          <p:nvPr/>
-        </p:nvSpPr>
-        <p:spPr>
-          <a:xfrm rot="0">
-            <a:off x="609600" y="4686300"/>
-            <a:ext cx="7334250" cy="604456"/>
-          </a:xfrm>
-          <a:prstGeom prst="rect">
-            <a:avLst/>
-          </a:prstGeom>
-        </p:spPr>
-        <p:txBody>
-          <a:bodyPr anchor="t" rtlCol="false" tIns="0" lIns="0" bIns="0" rIns="0">
-            <a:spAutoFit/>
-          </a:bodyPr>
-          <a:lstStyle/>
-          <a:p>
-            <a:pPr algn="l" marL="0" indent="0" lvl="0">
-              <a:lnSpc>
-                <a:spcPts val="2470"/>
-              </a:lnSpc>
-              <a:spcBef>
-                <a:spcPct val="0"/>
-              </a:spcBef>
-            </a:pPr>
-            <a:r>
-              <a:rPr lang="en-US" sz="2025" strike="noStrike" u="none">
-                <a:solidFill>
-                  <a:srgbClr val="0A2A66"/>
-                </a:solidFill>
-                <a:latin typeface="DM Sans"/>
-                <a:ea typeface="DM Sans"/>
-                <a:cs typeface="DM Sans"/>
-                <a:sym typeface="DM Sans"/>
-              </a:rPr>
-              <a:t>Follow the idea into a matching Khan exercise.</a:t>
-            </a:r>
-          </a:p>
-          <a:p>
-            <a:pPr algn="l" marL="0" indent="0" lvl="0">
-              <a:lnSpc>
-                <a:spcPts val="2470"/>
-              </a:lnSpc>
-              <a:spcBef>
-                <a:spcPct val="0"/>
-              </a:spcBef>
-            </a:pPr>
-            <a:r>
-              <a:rPr lang="en-US" sz="2025" strike="noStrike" u="none">
-                <a:solidFill>
-                  <a:srgbClr val="0A2A66"/>
-                </a:solidFill>
-                <a:latin typeface="DM Sans"/>
-                <a:ea typeface="DM Sans"/>
-                <a:cs typeface="DM Sans"/>
-                <a:sym typeface="DM Sans"/>
-              </a:rPr>
-              <a:t>Save it for a fresh question later.</a:t>
-            </a:r>
-          </a:p>
-        </p:txBody>
-      </p:sp>
-      <p:sp>
-        <p:nvSpPr>
-          <p:cNvPr name="TextBox 15" id="15"/>
+          <p:cNvPr name="TextBox 16" id="16"/>
           <p:cNvSpPr txBox="true"/>
           <p:nvPr/>
         </p:nvSpPr>
@@ -18938,241 +19459,16 @@
                 <a:ea typeface="DM Sans"/>
                 <a:cs typeface="DM Sans"/>
                 <a:sym typeface="DM Sans"/>
-                <a:hlinkClick r:id="rId9" tooltip="https://dunlo.vercel.app/explore"/>
+                <a:hlinkClick r:id="rId10" tooltip="https://dunlo.vercel.app/explore"/>
               </a:rPr>
               <a:t>Explore the working feed · dunlo.vercel.app/explore</a:t>
             </a:r>
           </a:p>
         </p:txBody>
       </p:sp>
-      <p:grpSp>
-        <p:nvGrpSpPr>
-          <p:cNvPr name="Group 16" id="16"/>
-          <p:cNvGrpSpPr/>
-          <p:nvPr/>
-        </p:nvGrpSpPr>
-        <p:grpSpPr>
-          <a:xfrm rot="0">
-            <a:off x="8477250" y="1495425"/>
-            <a:ext cx="2343150" cy="4972050"/>
-            <a:chOff x="0" y="0"/>
-            <a:chExt cx="925689" cy="1964267"/>
-          </a:xfrm>
-        </p:grpSpPr>
-        <p:sp>
-          <p:nvSpPr>
-            <p:cNvPr name="Freeform 17" id="17"/>
-            <p:cNvSpPr/>
-            <p:nvPr/>
-          </p:nvSpPr>
-          <p:spPr>
-            <a:xfrm flipH="false" flipV="false" rot="0">
-              <a:off x="0" y="0"/>
-              <a:ext cx="925689" cy="1964267"/>
-            </a:xfrm>
-            <a:custGeom>
-              <a:avLst/>
-              <a:gdLst/>
-              <a:ahLst/>
-              <a:cxnLst/>
-              <a:rect r="r" b="b" t="t" l="l"/>
-              <a:pathLst>
-                <a:path h="1964267" w="925689">
-                  <a:moveTo>
-                    <a:pt x="125554" y="0"/>
-                  </a:moveTo>
-                  <a:lnTo>
-                    <a:pt x="800134" y="0"/>
-                  </a:lnTo>
-                  <a:cubicBezTo>
-                    <a:pt x="833434" y="0"/>
-                    <a:pt x="865369" y="13228"/>
-                    <a:pt x="888915" y="36774"/>
-                  </a:cubicBezTo>
-                  <a:cubicBezTo>
-                    <a:pt x="912461" y="60320"/>
-                    <a:pt x="925689" y="92255"/>
-                    <a:pt x="925689" y="125554"/>
-                  </a:cubicBezTo>
-                  <a:lnTo>
-                    <a:pt x="925689" y="1838712"/>
-                  </a:lnTo>
-                  <a:cubicBezTo>
-                    <a:pt x="925689" y="1908054"/>
-                    <a:pt x="869476" y="1964267"/>
-                    <a:pt x="800134" y="1964267"/>
-                  </a:cubicBezTo>
-                  <a:lnTo>
-                    <a:pt x="125554" y="1964267"/>
-                  </a:lnTo>
-                  <a:cubicBezTo>
-                    <a:pt x="92255" y="1964267"/>
-                    <a:pt x="60320" y="1951039"/>
-                    <a:pt x="36774" y="1927493"/>
-                  </a:cubicBezTo>
-                  <a:cubicBezTo>
-                    <a:pt x="13228" y="1903947"/>
-                    <a:pt x="0" y="1872011"/>
-                    <a:pt x="0" y="1838712"/>
-                  </a:cubicBezTo>
-                  <a:lnTo>
-                    <a:pt x="0" y="125554"/>
-                  </a:lnTo>
-                  <a:cubicBezTo>
-                    <a:pt x="0" y="92255"/>
-                    <a:pt x="13228" y="60320"/>
-                    <a:pt x="36774" y="36774"/>
-                  </a:cubicBezTo>
-                  <a:cubicBezTo>
-                    <a:pt x="60320" y="13228"/>
-                    <a:pt x="92255" y="0"/>
-                    <a:pt x="125554" y="0"/>
-                  </a:cubicBezTo>
-                  <a:close/>
-                </a:path>
-              </a:pathLst>
-            </a:custGeom>
-            <a:solidFill>
-              <a:srgbClr val="15171B"/>
-            </a:solidFill>
-          </p:spPr>
-        </p:sp>
-        <p:sp>
-          <p:nvSpPr>
-            <p:cNvPr name="TextBox 18" id="18"/>
-            <p:cNvSpPr txBox="true"/>
-            <p:nvPr/>
-          </p:nvSpPr>
-          <p:spPr>
-            <a:xfrm>
-              <a:off x="0" y="0"/>
-              <a:ext cx="925689" cy="1964267"/>
-            </a:xfrm>
-            <a:prstGeom prst="rect">
-              <a:avLst/>
-            </a:prstGeom>
-          </p:spPr>
-          <p:txBody>
-            <a:bodyPr anchor="ctr" rtlCol="false" tIns="50800" lIns="50800" bIns="50800" rIns="50800"/>
-            <a:lstStyle/>
-            <a:p>
-              <a:pPr algn="ctr">
-                <a:lnSpc>
-                  <a:spcPts val="1372"/>
-                </a:lnSpc>
-              </a:pPr>
-            </a:p>
-          </p:txBody>
-        </p:sp>
-      </p:grpSp>
-      <p:grpSp>
-        <p:nvGrpSpPr>
-          <p:cNvPr name="Group 19" id="19"/>
-          <p:cNvGrpSpPr/>
-          <p:nvPr/>
-        </p:nvGrpSpPr>
-        <p:grpSpPr>
-          <a:xfrm rot="0">
-            <a:off x="9401175" y="1685925"/>
-            <a:ext cx="495300" cy="47625"/>
-            <a:chOff x="0" y="0"/>
-            <a:chExt cx="195674" cy="18815"/>
-          </a:xfrm>
-        </p:grpSpPr>
-        <p:sp>
-          <p:nvSpPr>
-            <p:cNvPr name="Freeform 20" id="20"/>
-            <p:cNvSpPr/>
-            <p:nvPr/>
-          </p:nvSpPr>
-          <p:spPr>
-            <a:xfrm flipH="false" flipV="false" rot="0">
-              <a:off x="0" y="0"/>
-              <a:ext cx="195674" cy="18815"/>
-            </a:xfrm>
-            <a:custGeom>
-              <a:avLst/>
-              <a:gdLst/>
-              <a:ahLst/>
-              <a:cxnLst/>
-              <a:rect r="r" b="b" t="t" l="l"/>
-              <a:pathLst>
-                <a:path h="18815" w="195674">
-                  <a:moveTo>
-                    <a:pt x="9407" y="0"/>
-                  </a:moveTo>
-                  <a:lnTo>
-                    <a:pt x="186267" y="0"/>
-                  </a:lnTo>
-                  <a:cubicBezTo>
-                    <a:pt x="191462" y="0"/>
-                    <a:pt x="195674" y="4212"/>
-                    <a:pt x="195674" y="9407"/>
-                  </a:cubicBezTo>
-                  <a:lnTo>
-                    <a:pt x="195674" y="9407"/>
-                  </a:lnTo>
-                  <a:cubicBezTo>
-                    <a:pt x="195674" y="14603"/>
-                    <a:pt x="191462" y="18815"/>
-                    <a:pt x="186267" y="18815"/>
-                  </a:cubicBezTo>
-                  <a:lnTo>
-                    <a:pt x="9407" y="18815"/>
-                  </a:lnTo>
-                  <a:cubicBezTo>
-                    <a:pt x="4212" y="18815"/>
-                    <a:pt x="0" y="14603"/>
-                    <a:pt x="0" y="9407"/>
-                  </a:cubicBezTo>
-                  <a:lnTo>
-                    <a:pt x="0" y="9407"/>
-                  </a:lnTo>
-                  <a:cubicBezTo>
-                    <a:pt x="0" y="4212"/>
-                    <a:pt x="4212" y="0"/>
-                    <a:pt x="9407" y="0"/>
-                  </a:cubicBezTo>
-                  <a:close/>
-                </a:path>
-              </a:pathLst>
-            </a:custGeom>
-            <a:solidFill>
-              <a:srgbClr val="555555"/>
-            </a:solidFill>
-          </p:spPr>
-        </p:sp>
-        <p:sp>
-          <p:nvSpPr>
-            <p:cNvPr name="TextBox 21" id="21"/>
-            <p:cNvSpPr txBox="true"/>
-            <p:nvPr/>
-          </p:nvSpPr>
-          <p:spPr>
-            <a:xfrm>
-              <a:off x="0" y="0"/>
-              <a:ext cx="195674" cy="18815"/>
-            </a:xfrm>
-            <a:prstGeom prst="rect">
-              <a:avLst/>
-            </a:prstGeom>
-          </p:spPr>
-          <p:txBody>
-            <a:bodyPr anchor="ctr" rtlCol="false" tIns="50800" lIns="50800" bIns="50800" rIns="50800"/>
-            <a:lstStyle/>
-            <a:p>
-              <a:pPr algn="ctr">
-                <a:lnSpc>
-                  <a:spcPts val="1372"/>
-                </a:lnSpc>
-              </a:pPr>
-            </a:p>
-          </p:txBody>
-        </p:sp>
-      </p:grpSp>
-      <p:sp>
-        <p:nvSpPr>
-          <p:cNvPr name="TextBox 22" id="22"/>
+      <p:sp>
+        <p:nvSpPr>
+          <p:cNvPr name="TextBox 17" id="17"/>
           <p:cNvSpPr txBox="true"/>
           <p:nvPr/>
         </p:nvSpPr>
@@ -19216,14 +19512,14 @@
       </p:sp>
       <p:sp>
         <p:nvSpPr>
-          <p:cNvPr name="Freeform 23" id="23" descr="Actual Dunlo mobile Explore screen, fully visible inside a phone mockup."/>
+          <p:cNvPr name="Freeform 18" id="18"/>
           <p:cNvSpPr/>
           <p:nvPr/>
         </p:nvSpPr>
         <p:spPr>
           <a:xfrm flipH="false" flipV="false" rot="0">
-            <a:off x="8648700" y="1885950"/>
-            <a:ext cx="2000250" cy="4336675"/>
+            <a:off x="9429750" y="323850"/>
+            <a:ext cx="2152650" cy="133350"/>
           </a:xfrm>
           <a:custGeom>
             <a:avLst/>
@@ -19232,18 +19528,18 @@
             <a:cxnLst/>
             <a:rect r="r" b="b" t="t" l="l"/>
             <a:pathLst>
-              <a:path h="4336675" w="2000250">
+              <a:path h="133350" w="2152650">
                 <a:moveTo>
                   <a:pt x="0" y="0"/>
                 </a:moveTo>
                 <a:lnTo>
-                  <a:pt x="2000250" y="0"/>
+                  <a:pt x="2152650" y="0"/>
                 </a:lnTo>
                 <a:lnTo>
-                  <a:pt x="2000250" y="4336675"/>
+                  <a:pt x="2152650" y="133350"/>
                 </a:lnTo>
                 <a:lnTo>
-                  <a:pt x="0" y="4336675"/>
+                  <a:pt x="0" y="133350"/>
                 </a:lnTo>
                 <a:lnTo>
                   <a:pt x="0" y="0"/>
@@ -19253,118 +19549,19 @@
             </a:pathLst>
           </a:custGeom>
           <a:blipFill>
-            <a:blip r:embed="rId10"/>
+            <a:blip r:embed="rId11">
+              <a:extLst>
+                <a:ext uri="{96DAC541-7B7A-43D3-8B79-37D633B846F1}">
+                  <asvg:svgBlip xmlns:asvg="http://schemas.microsoft.com/office/drawing/2016/SVG/main" r:embed="rId12"/>
+                </a:ext>
+              </a:extLst>
+            </a:blip>
             <a:stretch>
-              <a:fillRect l="-1" t="0" r="-1" b="0"/>
+              <a:fillRect l="0" t="-1363" r="0" b="-1363"/>
             </a:stretch>
           </a:blipFill>
         </p:spPr>
       </p:sp>
-      <p:grpSp>
-        <p:nvGrpSpPr>
-          <p:cNvPr name="Group 24" id="24"/>
-          <p:cNvGrpSpPr/>
-          <p:nvPr/>
-        </p:nvGrpSpPr>
-        <p:grpSpPr>
-          <a:xfrm rot="0">
-            <a:off x="9401175" y="6334125"/>
-            <a:ext cx="495300" cy="47625"/>
-            <a:chOff x="0" y="0"/>
-            <a:chExt cx="195674" cy="18815"/>
-          </a:xfrm>
-        </p:grpSpPr>
-        <p:sp>
-          <p:nvSpPr>
-            <p:cNvPr name="Freeform 25" id="25"/>
-            <p:cNvSpPr/>
-            <p:nvPr/>
-          </p:nvSpPr>
-          <p:spPr>
-            <a:xfrm flipH="false" flipV="false" rot="0">
-              <a:off x="0" y="0"/>
-              <a:ext cx="195674" cy="18815"/>
-            </a:xfrm>
-            <a:custGeom>
-              <a:avLst/>
-              <a:gdLst/>
-              <a:ahLst/>
-              <a:cxnLst/>
-              <a:rect r="r" b="b" t="t" l="l"/>
-              <a:pathLst>
-                <a:path h="18815" w="195674">
-                  <a:moveTo>
-                    <a:pt x="9407" y="0"/>
-                  </a:moveTo>
-                  <a:lnTo>
-                    <a:pt x="186267" y="0"/>
-                  </a:lnTo>
-                  <a:cubicBezTo>
-                    <a:pt x="191462" y="0"/>
-                    <a:pt x="195674" y="4212"/>
-                    <a:pt x="195674" y="9407"/>
-                  </a:cubicBezTo>
-                  <a:lnTo>
-                    <a:pt x="195674" y="9407"/>
-                  </a:lnTo>
-                  <a:cubicBezTo>
-                    <a:pt x="195674" y="14603"/>
-                    <a:pt x="191462" y="18815"/>
-                    <a:pt x="186267" y="18815"/>
-                  </a:cubicBezTo>
-                  <a:lnTo>
-                    <a:pt x="9407" y="18815"/>
-                  </a:lnTo>
-                  <a:cubicBezTo>
-                    <a:pt x="4212" y="18815"/>
-                    <a:pt x="0" y="14603"/>
-                    <a:pt x="0" y="9407"/>
-                  </a:cubicBezTo>
-                  <a:lnTo>
-                    <a:pt x="0" y="9407"/>
-                  </a:lnTo>
-                  <a:cubicBezTo>
-                    <a:pt x="0" y="4212"/>
-                    <a:pt x="4212" y="0"/>
-                    <a:pt x="9407" y="0"/>
-                  </a:cubicBezTo>
-                  <a:close/>
-                </a:path>
-              </a:pathLst>
-            </a:custGeom>
-            <a:solidFill>
-              <a:srgbClr val="555555"/>
-            </a:solidFill>
-          </p:spPr>
-        </p:sp>
-        <p:sp>
-          <p:nvSpPr>
-            <p:cNvPr name="TextBox 26" id="26"/>
-            <p:cNvSpPr txBox="true"/>
-            <p:nvPr/>
-          </p:nvSpPr>
-          <p:spPr>
-            <a:xfrm>
-              <a:off x="0" y="0"/>
-              <a:ext cx="195674" cy="18815"/>
-            </a:xfrm>
-            <a:prstGeom prst="rect">
-              <a:avLst/>
-            </a:prstGeom>
-          </p:spPr>
-          <p:txBody>
-            <a:bodyPr anchor="ctr" rtlCol="false" tIns="50800" lIns="50800" bIns="50800" rIns="50800"/>
-            <a:lstStyle/>
-            <a:p>
-              <a:pPr algn="ctr">
-                <a:lnSpc>
-                  <a:spcPts val="1372"/>
-                </a:lnSpc>
-              </a:pPr>
-            </a:p>
-          </p:txBody>
-        </p:sp>
-      </p:grpSp>
     </p:spTree>
   </p:cSld>
   <p:clrMapOvr>
@@ -20585,6 +20782,58 @@
           </a:blipFill>
         </p:spPr>
       </p:sp>
+      <p:sp>
+        <p:nvSpPr>
+          <p:cNvPr name="Freeform 33" id="33"/>
+          <p:cNvSpPr/>
+          <p:nvPr/>
+        </p:nvSpPr>
+        <p:spPr>
+          <a:xfrm flipH="false" flipV="false" rot="0">
+            <a:off x="9429750" y="323850"/>
+            <a:ext cx="2152650" cy="133350"/>
+          </a:xfrm>
+          <a:custGeom>
+            <a:avLst/>
+            <a:gdLst/>
+            <a:ahLst/>
+            <a:cxnLst/>
+            <a:rect r="r" b="b" t="t" l="l"/>
+            <a:pathLst>
+              <a:path h="133350" w="2152650">
+                <a:moveTo>
+                  <a:pt x="0" y="0"/>
+                </a:moveTo>
+                <a:lnTo>
+                  <a:pt x="2152650" y="0"/>
+                </a:lnTo>
+                <a:lnTo>
+                  <a:pt x="2152650" y="133350"/>
+                </a:lnTo>
+                <a:lnTo>
+                  <a:pt x="0" y="133350"/>
+                </a:lnTo>
+                <a:lnTo>
+                  <a:pt x="0" y="0"/>
+                </a:lnTo>
+                <a:close/>
+              </a:path>
+            </a:pathLst>
+          </a:custGeom>
+          <a:blipFill>
+            <a:blip r:embed="rId11">
+              <a:extLst>
+                <a:ext uri="{96DAC541-7B7A-43D3-8B79-37D633B846F1}">
+                  <asvg:svgBlip xmlns:asvg="http://schemas.microsoft.com/office/drawing/2016/SVG/main" r:embed="rId12"/>
+                </a:ext>
+              </a:extLst>
+            </a:blip>
+            <a:stretch>
+              <a:fillRect l="0" t="-1363" r="0" b="-1363"/>
+            </a:stretch>
+          </a:blipFill>
+        </p:spPr>
+      </p:sp>
     </p:spTree>
   </p:cSld>
   <p:clrMapOvr>
@@ -21252,6 +21501,58 @@
             <a:blip r:embed="rId10"/>
             <a:stretch>
               <a:fillRect l="0" t="-29" r="0" b="-29"/>
+            </a:stretch>
+          </a:blipFill>
+        </p:spPr>
+      </p:sp>
+      <p:sp>
+        <p:nvSpPr>
+          <p:cNvPr name="Freeform 17" id="17"/>
+          <p:cNvSpPr/>
+          <p:nvPr/>
+        </p:nvSpPr>
+        <p:spPr>
+          <a:xfrm flipH="false" flipV="false" rot="0">
+            <a:off x="9429750" y="323850"/>
+            <a:ext cx="2152650" cy="133350"/>
+          </a:xfrm>
+          <a:custGeom>
+            <a:avLst/>
+            <a:gdLst/>
+            <a:ahLst/>
+            <a:cxnLst/>
+            <a:rect r="r" b="b" t="t" l="l"/>
+            <a:pathLst>
+              <a:path h="133350" w="2152650">
+                <a:moveTo>
+                  <a:pt x="0" y="0"/>
+                </a:moveTo>
+                <a:lnTo>
+                  <a:pt x="2152650" y="0"/>
+                </a:lnTo>
+                <a:lnTo>
+                  <a:pt x="2152650" y="133350"/>
+                </a:lnTo>
+                <a:lnTo>
+                  <a:pt x="0" y="133350"/>
+                </a:lnTo>
+                <a:lnTo>
+                  <a:pt x="0" y="0"/>
+                </a:lnTo>
+                <a:close/>
+              </a:path>
+            </a:pathLst>
+          </a:custGeom>
+          <a:blipFill>
+            <a:blip r:embed="rId11">
+              <a:extLst>
+                <a:ext uri="{96DAC541-7B7A-43D3-8B79-37D633B846F1}">
+                  <asvg:svgBlip xmlns:asvg="http://schemas.microsoft.com/office/drawing/2016/SVG/main" r:embed="rId12"/>
+                </a:ext>
+              </a:extLst>
+            </a:blip>
+            <a:stretch>
+              <a:fillRect l="0" t="-1363" r="0" b="-1363"/>
             </a:stretch>
           </a:blipFill>
         </p:spPr>
@@ -22625,6 +22926,58 @@
           </a:blipFill>
         </p:spPr>
       </p:sp>
+      <p:sp>
+        <p:nvSpPr>
+          <p:cNvPr name="Freeform 37" id="37"/>
+          <p:cNvSpPr/>
+          <p:nvPr/>
+        </p:nvSpPr>
+        <p:spPr>
+          <a:xfrm flipH="false" flipV="false" rot="0">
+            <a:off x="9429750" y="323850"/>
+            <a:ext cx="2152650" cy="133350"/>
+          </a:xfrm>
+          <a:custGeom>
+            <a:avLst/>
+            <a:gdLst/>
+            <a:ahLst/>
+            <a:cxnLst/>
+            <a:rect r="r" b="b" t="t" l="l"/>
+            <a:pathLst>
+              <a:path h="133350" w="2152650">
+                <a:moveTo>
+                  <a:pt x="0" y="0"/>
+                </a:moveTo>
+                <a:lnTo>
+                  <a:pt x="2152650" y="0"/>
+                </a:lnTo>
+                <a:lnTo>
+                  <a:pt x="2152650" y="133350"/>
+                </a:lnTo>
+                <a:lnTo>
+                  <a:pt x="0" y="133350"/>
+                </a:lnTo>
+                <a:lnTo>
+                  <a:pt x="0" y="0"/>
+                </a:lnTo>
+                <a:close/>
+              </a:path>
+            </a:pathLst>
+          </a:custGeom>
+          <a:blipFill>
+            <a:blip r:embed="rId10">
+              <a:extLst>
+                <a:ext uri="{96DAC541-7B7A-43D3-8B79-37D633B846F1}">
+                  <asvg:svgBlip xmlns:asvg="http://schemas.microsoft.com/office/drawing/2016/SVG/main" r:embed="rId11"/>
+                </a:ext>
+              </a:extLst>
+            </a:blip>
+            <a:stretch>
+              <a:fillRect l="0" t="-1363" r="0" b="-1363"/>
+            </a:stretch>
+          </a:blipFill>
+        </p:spPr>
+      </p:sp>
     </p:spTree>
   </p:cSld>
   <p:clrMapOvr>
@@ -23434,6 +23787,58 @@
             </a:blip>
             <a:stretch>
               <a:fillRect l="0" t="0" r="0" b="0"/>
+            </a:stretch>
+          </a:blipFill>
+        </p:spPr>
+      </p:sp>
+      <p:sp>
+        <p:nvSpPr>
+          <p:cNvPr name="Freeform 22" id="22"/>
+          <p:cNvSpPr/>
+          <p:nvPr/>
+        </p:nvSpPr>
+        <p:spPr>
+          <a:xfrm flipH="false" flipV="false" rot="0">
+            <a:off x="9429750" y="323850"/>
+            <a:ext cx="2152650" cy="133350"/>
+          </a:xfrm>
+          <a:custGeom>
+            <a:avLst/>
+            <a:gdLst/>
+            <a:ahLst/>
+            <a:cxnLst/>
+            <a:rect r="r" b="b" t="t" l="l"/>
+            <a:pathLst>
+              <a:path h="133350" w="2152650">
+                <a:moveTo>
+                  <a:pt x="0" y="0"/>
+                </a:moveTo>
+                <a:lnTo>
+                  <a:pt x="2152650" y="0"/>
+                </a:lnTo>
+                <a:lnTo>
+                  <a:pt x="2152650" y="133350"/>
+                </a:lnTo>
+                <a:lnTo>
+                  <a:pt x="0" y="133350"/>
+                </a:lnTo>
+                <a:lnTo>
+                  <a:pt x="0" y="0"/>
+                </a:lnTo>
+                <a:close/>
+              </a:path>
+            </a:pathLst>
+          </a:custGeom>
+          <a:blipFill>
+            <a:blip r:embed="rId14">
+              <a:extLst>
+                <a:ext uri="{96DAC541-7B7A-43D3-8B79-37D633B846F1}">
+                  <asvg:svgBlip xmlns:asvg="http://schemas.microsoft.com/office/drawing/2016/SVG/main" r:embed="rId15"/>
+                </a:ext>
+              </a:extLst>
+            </a:blip>
+            <a:stretch>
+              <a:fillRect l="0" t="-1363" r="0" b="-1363"/>
             </a:stretch>
           </a:blipFill>
         </p:spPr>
@@ -24894,6 +25299,58 @@
             <a:blip r:embed="rId10"/>
             <a:stretch>
               <a:fillRect l="0" t="-1" r="0" b="-1"/>
+            </a:stretch>
+          </a:blipFill>
+        </p:spPr>
+      </p:sp>
+      <p:sp>
+        <p:nvSpPr>
+          <p:cNvPr name="Freeform 37" id="37"/>
+          <p:cNvSpPr/>
+          <p:nvPr/>
+        </p:nvSpPr>
+        <p:spPr>
+          <a:xfrm flipH="false" flipV="false" rot="0">
+            <a:off x="9429750" y="323850"/>
+            <a:ext cx="2152650" cy="133350"/>
+          </a:xfrm>
+          <a:custGeom>
+            <a:avLst/>
+            <a:gdLst/>
+            <a:ahLst/>
+            <a:cxnLst/>
+            <a:rect r="r" b="b" t="t" l="l"/>
+            <a:pathLst>
+              <a:path h="133350" w="2152650">
+                <a:moveTo>
+                  <a:pt x="0" y="0"/>
+                </a:moveTo>
+                <a:lnTo>
+                  <a:pt x="2152650" y="0"/>
+                </a:lnTo>
+                <a:lnTo>
+                  <a:pt x="2152650" y="133350"/>
+                </a:lnTo>
+                <a:lnTo>
+                  <a:pt x="0" y="133350"/>
+                </a:lnTo>
+                <a:lnTo>
+                  <a:pt x="0" y="0"/>
+                </a:lnTo>
+                <a:close/>
+              </a:path>
+            </a:pathLst>
+          </a:custGeom>
+          <a:blipFill>
+            <a:blip r:embed="rId11">
+              <a:extLst>
+                <a:ext uri="{96DAC541-7B7A-43D3-8B79-37D633B846F1}">
+                  <asvg:svgBlip xmlns:asvg="http://schemas.microsoft.com/office/drawing/2016/SVG/main" r:embed="rId12"/>
+                </a:ext>
+              </a:extLst>
+            </a:blip>
+            <a:stretch>
+              <a:fillRect l="0" t="-1363" r="0" b="-1363"/>
             </a:stretch>
           </a:blipFill>
         </p:spPr>

</xml_diff>